<commit_message>
Merged message_bus with redis persistence
</commit_message>
<xml_diff>
--- a/Presentation.pptx
+++ b/Presentation.pptx
@@ -213,7 +213,7 @@
           <a:p>
             <a:fld id="{F214320D-9E3A-43B2-B232-402D78146534}" type="datetimeFigureOut">
               <a:rPr lang="en-CA" smtClean="0"/>
-              <a:t>2025-07-03</a:t>
+              <a:t>2025-07-07</a:t>
             </a:fld>
             <a:endParaRPr lang="en-CA"/>
           </a:p>
@@ -1390,7 +1390,7 @@
           <a:p>
             <a:fld id="{C128FA71-3A18-48C0-980F-4B68F7F63042}" type="datetime1">
               <a:rPr lang="en-US" smtClean="0"/>
-              <a:t>7/3/2025</a:t>
+              <a:t>7/7/2025</a:t>
             </a:fld>
             <a:endParaRPr lang="en-US"/>
           </a:p>
@@ -1598,7 +1598,7 @@
           <a:p>
             <a:fld id="{7104EDB3-C0E8-45F8-9E1D-1B6C8D1880C0}" type="datetime1">
               <a:rPr lang="en-US" smtClean="0"/>
-              <a:t>7/3/2025</a:t>
+              <a:t>7/7/2025</a:t>
             </a:fld>
             <a:endParaRPr lang="en-US"/>
           </a:p>
@@ -1808,7 +1808,7 @@
           <a:p>
             <a:fld id="{9CF0EC4B-54ED-4041-B552-9BA760FA3DBA}" type="datetime1">
               <a:rPr lang="en-US" smtClean="0"/>
-              <a:t>7/3/2025</a:t>
+              <a:t>7/7/2025</a:t>
             </a:fld>
             <a:endParaRPr lang="en-US"/>
           </a:p>
@@ -2006,7 +2006,7 @@
           <a:p>
             <a:fld id="{51C1210E-201E-4473-82AC-2466F5386C38}" type="datetime1">
               <a:rPr lang="en-US" smtClean="0"/>
-              <a:t>7/3/2025</a:t>
+              <a:t>7/7/2025</a:t>
             </a:fld>
             <a:endParaRPr lang="en-US"/>
           </a:p>
@@ -2284,7 +2284,7 @@
           <a:p>
             <a:fld id="{B01EA198-6CAB-4B8F-B93F-1F9C8C4B6CE7}" type="datetime1">
               <a:rPr lang="en-US" smtClean="0"/>
-              <a:t>7/3/2025</a:t>
+              <a:t>7/7/2025</a:t>
             </a:fld>
             <a:endParaRPr lang="en-US"/>
           </a:p>
@@ -2556,7 +2556,7 @@
           <a:p>
             <a:fld id="{CA06041F-4525-44D5-AA4F-332294BF1F56}" type="datetime1">
               <a:rPr lang="en-US" smtClean="0"/>
-              <a:t>7/3/2025</a:t>
+              <a:t>7/7/2025</a:t>
             </a:fld>
             <a:endParaRPr lang="en-US"/>
           </a:p>
@@ -2980,7 +2980,7 @@
           <a:p>
             <a:fld id="{F9557091-BBDF-4EB9-BA6B-2BB67AC4FC0F}" type="datetime1">
               <a:rPr lang="en-US" smtClean="0"/>
-              <a:t>7/3/2025</a:t>
+              <a:t>7/7/2025</a:t>
             </a:fld>
             <a:endParaRPr lang="en-US"/>
           </a:p>
@@ -3121,7 +3121,7 @@
           <a:p>
             <a:fld id="{2D6B226B-77A6-410C-9796-083F278E0125}" type="datetime1">
               <a:rPr lang="en-US" smtClean="0"/>
-              <a:t>7/3/2025</a:t>
+              <a:t>7/7/2025</a:t>
             </a:fld>
             <a:endParaRPr lang="en-US"/>
           </a:p>
@@ -3234,7 +3234,7 @@
           <a:p>
             <a:fld id="{A23A578B-D289-4C40-8593-3D356C49DA58}" type="datetime1">
               <a:rPr lang="en-US" smtClean="0"/>
-              <a:t>7/3/2025</a:t>
+              <a:t>7/7/2025</a:t>
             </a:fld>
             <a:endParaRPr lang="en-US"/>
           </a:p>
@@ -3553,7 +3553,7 @@
           <a:p>
             <a:fld id="{713DFAE3-14DB-48A7-A80F-80DDB072CE3D}" type="datetime1">
               <a:rPr lang="en-US" smtClean="0"/>
-              <a:t>7/3/2025</a:t>
+              <a:t>7/7/2025</a:t>
             </a:fld>
             <a:endParaRPr lang="en-US"/>
           </a:p>
@@ -3847,7 +3847,7 @@
           <a:p>
             <a:fld id="{92C5EAEF-6478-4102-8F5D-A5FE9FC97ACB}" type="datetime1">
               <a:rPr lang="en-US" smtClean="0"/>
-              <a:t>7/3/2025</a:t>
+              <a:t>7/7/2025</a:t>
             </a:fld>
             <a:endParaRPr lang="en-US"/>
           </a:p>
@@ -4088,7 +4088,7 @@
           <a:p>
             <a:fld id="{67F45AC6-C491-4585-A584-9CE2AF7D5500}" type="datetime1">
               <a:rPr lang="en-US" smtClean="0"/>
-              <a:t>7/3/2025</a:t>
+              <a:t>7/7/2025</a:t>
             </a:fld>
             <a:endParaRPr lang="en-US"/>
           </a:p>
@@ -6260,22 +6260,28 @@
               <a:rPr lang="en-US" b="1" dirty="0">
                 <a:cs typeface="Courier New" panose="02070309020205020404" pitchFamily="49" charset="0"/>
               </a:rPr>
-              <a:t>v8 (paused)</a:t>
+              <a:t>v8</a:t>
             </a:r>
           </a:p>
           <a:p>
             <a:pPr lvl="1"/>
             <a:r>
+              <a:rPr lang="en-US" b="1" dirty="0">
+                <a:cs typeface="Courier New" panose="02070309020205020404" pitchFamily="49" charset="0"/>
+              </a:rPr>
+              <a:t>Added</a:t>
+            </a:r>
+            <a:r>
               <a:rPr lang="en-US" dirty="0">
                 <a:cs typeface="Courier New" panose="02070309020205020404" pitchFamily="49" charset="0"/>
               </a:rPr>
-              <a:t>Add Redis</a:t>
+              <a:t> Redis</a:t>
             </a:r>
           </a:p>
           <a:p>
             <a:pPr lvl="2"/>
             <a:r>
-              <a:rPr lang="en-US">
+              <a:rPr lang="en-US" dirty="0">
                 <a:cs typeface="Courier New" panose="02070309020205020404" pitchFamily="49" charset="0"/>
               </a:rPr>
               <a:t>To improve </a:t>
@@ -6306,42 +6312,6 @@
           </a:p>
         </p:txBody>
       </p:sp>
-      <p:pic>
-        <p:nvPicPr>
-          <p:cNvPr id="5" name="Picture 4" descr="A red triangle on a black background&#10;&#10;AI-generated content may be incorrect.">
-            <a:extLst>
-              <a:ext uri="{FF2B5EF4-FFF2-40B4-BE49-F238E27FC236}">
-                <a16:creationId xmlns:a16="http://schemas.microsoft.com/office/drawing/2014/main" id="{1D865A46-3BC3-194E-ED41-0C4012E6EF9D}"/>
-              </a:ext>
-            </a:extLst>
-          </p:cNvPr>
-          <p:cNvPicPr>
-            <a:picLocks noChangeAspect="1"/>
-          </p:cNvPicPr>
-          <p:nvPr/>
-        </p:nvPicPr>
-        <p:blipFill>
-          <a:blip r:embed="rId4">
-            <a:extLst>
-              <a:ext uri="{28A0092B-C50C-407E-A947-70E740481C1C}">
-                <a14:useLocalDpi xmlns:a14="http://schemas.microsoft.com/office/drawing/2010/main" val="0"/>
-              </a:ext>
-            </a:extLst>
-          </a:blip>
-          <a:stretch>
-            <a:fillRect/>
-          </a:stretch>
-        </p:blipFill>
-        <p:spPr>
-          <a:xfrm>
-            <a:off x="3129254" y="4986638"/>
-            <a:ext cx="421518" cy="421518"/>
-          </a:xfrm>
-          <a:prstGeom prst="rect">
-            <a:avLst/>
-          </a:prstGeom>
-        </p:spPr>
-      </p:pic>
     </p:spTree>
     <p:extLst>
       <p:ext uri="{BB962C8B-B14F-4D97-AF65-F5344CB8AC3E}">
@@ -6452,10 +6422,16 @@
           <a:p>
             <a:pPr lvl="1"/>
             <a:r>
+              <a:rPr lang="en-US" b="1" dirty="0">
+                <a:cs typeface="Courier New" panose="02070309020205020404" pitchFamily="49" charset="0"/>
+              </a:rPr>
+              <a:t>Refactor</a:t>
+            </a:r>
+            <a:r>
               <a:rPr lang="en-US" dirty="0">
                 <a:cs typeface="Courier New" panose="02070309020205020404" pitchFamily="49" charset="0"/>
               </a:rPr>
-              <a:t>Refactor to solve Windows </a:t>
+              <a:t> to solve Windows </a:t>
             </a:r>
             <a:r>
               <a:rPr lang="en-US" i="1" dirty="0">
@@ -6468,6 +6444,21 @@
                 <a:cs typeface="Courier New" panose="02070309020205020404" pitchFamily="49" charset="0"/>
               </a:rPr>
               <a:t> issues</a:t>
+            </a:r>
+          </a:p>
+          <a:p>
+            <a:pPr lvl="1"/>
+            <a:r>
+              <a:rPr lang="en-US" b="1" dirty="0">
+                <a:cs typeface="Courier New" panose="02070309020205020404" pitchFamily="49" charset="0"/>
+              </a:rPr>
+              <a:t>Added</a:t>
+            </a:r>
+            <a:r>
+              <a:rPr lang="en-US" dirty="0">
+                <a:cs typeface="Courier New" panose="02070309020205020404" pitchFamily="49" charset="0"/>
+              </a:rPr>
+              <a:t> Redis message-bus</a:t>
             </a:r>
           </a:p>
           <a:p>
@@ -6478,42 +6469,6 @@
           </a:p>
         </p:txBody>
       </p:sp>
-      <p:pic>
-        <p:nvPicPr>
-          <p:cNvPr id="4" name="Picture 3" descr="A red triangle on a black background&#10;&#10;AI-generated content may be incorrect.">
-            <a:extLst>
-              <a:ext uri="{FF2B5EF4-FFF2-40B4-BE49-F238E27FC236}">
-                <a16:creationId xmlns:a16="http://schemas.microsoft.com/office/drawing/2014/main" id="{D215C76C-F82F-BCA9-08BB-344489E59E2C}"/>
-              </a:ext>
-            </a:extLst>
-          </p:cNvPr>
-          <p:cNvPicPr>
-            <a:picLocks noChangeAspect="1"/>
-          </p:cNvPicPr>
-          <p:nvPr/>
-        </p:nvPicPr>
-        <p:blipFill>
-          <a:blip r:embed="rId3">
-            <a:extLst>
-              <a:ext uri="{28A0092B-C50C-407E-A947-70E740481C1C}">
-                <a14:useLocalDpi xmlns:a14="http://schemas.microsoft.com/office/drawing/2010/main" val="0"/>
-              </a:ext>
-            </a:extLst>
-          </a:blip>
-          <a:stretch>
-            <a:fillRect/>
-          </a:stretch>
-        </p:blipFill>
-        <p:spPr>
-          <a:xfrm>
-            <a:off x="5540086" y="2119186"/>
-            <a:ext cx="421518" cy="421518"/>
-          </a:xfrm>
-          <a:prstGeom prst="rect">
-            <a:avLst/>
-          </a:prstGeom>
-        </p:spPr>
-      </p:pic>
     </p:spTree>
     <p:extLst>
       <p:ext uri="{BB962C8B-B14F-4D97-AF65-F5344CB8AC3E}">

</xml_diff>

<commit_message>
Simplified architecture: Each nsp_client has its own monitor daemon
</commit_message>
<xml_diff>
--- a/Presentation.pptx
+++ b/Presentation.pptx
@@ -4772,7 +4772,7 @@
             </a:r>
             <a:r>
               <a:rPr lang="en-US" sz="1800" b="0" dirty="0"/>
-              <a:t>v8</a:t>
+              <a:t>v8+</a:t>
             </a:r>
             <a:br>
               <a:rPr lang="en-US" sz="5200" dirty="0"/>
@@ -4838,6 +4838,16 @@
           <a:p>
             <a:pPr algn="l"/>
             <a:r>
+              <a:rPr lang="en-US" sz="1400">
+                <a:solidFill>
+                  <a:schemeClr val="tx1">
+                    <a:lumMod val="85000"/>
+                  </a:schemeClr>
+                </a:solidFill>
+              </a:rPr>
+              <a:t>July </a:t>
+            </a:r>
+            <a:r>
               <a:rPr lang="en-US" sz="1400" dirty="0">
                 <a:solidFill>
                   <a:schemeClr val="tx1">
@@ -4845,7 +4855,7 @@
                   </a:schemeClr>
                 </a:solidFill>
               </a:rPr>
-              <a:t>June 2025</a:t>
+              <a:t>2025</a:t>
             </a:r>
             <a:endParaRPr lang="en-CA" sz="1400" dirty="0">
               <a:solidFill>
@@ -6189,93 +6199,87 @@
               <a:rPr lang="en-US" dirty="0">
                 <a:cs typeface="Courier New" panose="02070309020205020404" pitchFamily="49" charset="0"/>
               </a:rPr>
-              <a:t> loops (ongoing)</a:t>
+              <a:t> loops</a:t>
+            </a:r>
+          </a:p>
+          <a:p>
+            <a:pPr lvl="1"/>
+            <a:r>
+              <a:rPr lang="en-US" b="1" dirty="0">
+                <a:cs typeface="Courier New" panose="02070309020205020404" pitchFamily="49" charset="0"/>
+              </a:rPr>
+              <a:t>Added</a:t>
+            </a:r>
+            <a:r>
+              <a:rPr lang="en-US" dirty="0">
+                <a:cs typeface="Courier New" panose="02070309020205020404" pitchFamily="49" charset="0"/>
+              </a:rPr>
+              <a:t> multi-model</a:t>
             </a:r>
           </a:p>
           <a:p>
             <a:pPr lvl="2"/>
             <a:r>
+              <a:rPr lang="en-US" dirty="0">
+                <a:cs typeface="Courier New" panose="02070309020205020404" pitchFamily="49" charset="0"/>
+              </a:rPr>
+              <a:t>Two Agents</a:t>
+            </a:r>
+          </a:p>
+          <a:p>
+            <a:pPr lvl="3"/>
+            <a:r>
+              <a:rPr lang="en-US" dirty="0">
+                <a:cs typeface="Courier New" panose="02070309020205020404" pitchFamily="49" charset="0"/>
+              </a:rPr>
+              <a:t>One Agent uses tools to research the alarms</a:t>
+            </a:r>
+          </a:p>
+          <a:p>
+            <a:pPr lvl="3"/>
+            <a:r>
+              <a:rPr lang="en-US" dirty="0">
+                <a:cs typeface="Courier New" panose="02070309020205020404" pitchFamily="49" charset="0"/>
+              </a:rPr>
+              <a:t>Another Agent to do the RCA</a:t>
+            </a:r>
+          </a:p>
+          <a:p>
+            <a:r>
+              <a:rPr lang="en-US" dirty="0">
+                <a:cs typeface="Courier New" panose="02070309020205020404" pitchFamily="49" charset="0"/>
+              </a:rPr>
+              <a:t>v7 -&gt; </a:t>
+            </a:r>
+            <a:r>
               <a:rPr lang="en-US" b="1" dirty="0">
                 <a:cs typeface="Courier New" panose="02070309020205020404" pitchFamily="49" charset="0"/>
               </a:rPr>
-              <a:t>TODO: </a:t>
+              <a:t>v8</a:t>
+            </a:r>
+          </a:p>
+          <a:p>
+            <a:pPr lvl="1"/>
+            <a:r>
+              <a:rPr lang="en-US" b="1" dirty="0">
+                <a:cs typeface="Courier New" panose="02070309020205020404" pitchFamily="49" charset="0"/>
+              </a:rPr>
+              <a:t>Added</a:t>
             </a:r>
             <a:r>
               <a:rPr lang="en-US" dirty="0">
                 <a:cs typeface="Courier New" panose="02070309020205020404" pitchFamily="49" charset="0"/>
               </a:rPr>
-              <a:t>Handle parallel NE chains</a:t>
-            </a:r>
-          </a:p>
-          <a:p>
-            <a:pPr lvl="1"/>
-            <a:r>
-              <a:rPr lang="en-US" b="1" dirty="0">
-                <a:cs typeface="Courier New" panose="02070309020205020404" pitchFamily="49" charset="0"/>
-              </a:rPr>
-              <a:t>Added</a:t>
-            </a:r>
+              <a:t> Redis </a:t>
+            </a:r>
+          </a:p>
+          <a:p>
+            <a:pPr lvl="2"/>
             <a:r>
               <a:rPr lang="en-US" dirty="0">
                 <a:cs typeface="Courier New" panose="02070309020205020404" pitchFamily="49" charset="0"/>
               </a:rPr>
-              <a:t> multi-model</a:t>
-            </a:r>
-          </a:p>
-          <a:p>
-            <a:pPr lvl="2"/>
-            <a:r>
-              <a:rPr lang="en-US" dirty="0">
-                <a:cs typeface="Courier New" panose="02070309020205020404" pitchFamily="49" charset="0"/>
-              </a:rPr>
-              <a:t>Two Agents</a:t>
-            </a:r>
-          </a:p>
-          <a:p>
-            <a:pPr lvl="3"/>
-            <a:r>
-              <a:rPr lang="en-US" dirty="0">
-                <a:cs typeface="Courier New" panose="02070309020205020404" pitchFamily="49" charset="0"/>
-              </a:rPr>
-              <a:t>One Agent uses tools to research the alarms</a:t>
-            </a:r>
-          </a:p>
-          <a:p>
-            <a:pPr lvl="3"/>
-            <a:r>
-              <a:rPr lang="en-US" dirty="0">
-                <a:cs typeface="Courier New" panose="02070309020205020404" pitchFamily="49" charset="0"/>
-              </a:rPr>
-              <a:t>Another Agent performs the RCA</a:t>
-            </a:r>
-          </a:p>
-          <a:p>
-            <a:r>
-              <a:rPr lang="en-US" dirty="0">
-                <a:cs typeface="Courier New" panose="02070309020205020404" pitchFamily="49" charset="0"/>
-              </a:rPr>
-              <a:t>v7 -&gt; </a:t>
-            </a:r>
-            <a:r>
-              <a:rPr lang="en-US" b="1" dirty="0">
-                <a:cs typeface="Courier New" panose="02070309020205020404" pitchFamily="49" charset="0"/>
-              </a:rPr>
-              <a:t>v8</a:t>
-            </a:r>
-          </a:p>
-          <a:p>
-            <a:pPr lvl="1"/>
-            <a:r>
-              <a:rPr lang="en-US" b="1" dirty="0">
-                <a:cs typeface="Courier New" panose="02070309020205020404" pitchFamily="49" charset="0"/>
-              </a:rPr>
-              <a:t>Added</a:t>
-            </a:r>
-            <a:r>
-              <a:rPr lang="en-US" dirty="0">
-                <a:cs typeface="Courier New" panose="02070309020205020404" pitchFamily="49" charset="0"/>
-              </a:rPr>
-              <a:t> Redis</a:t>
+              <a:t>Store tools outputs</a:t>
             </a:r>
           </a:p>
           <a:p>
@@ -6462,6 +6466,42 @@
             </a:r>
           </a:p>
           <a:p>
+            <a:r>
+              <a:rPr lang="en-US" dirty="0">
+                <a:cs typeface="Courier New" panose="02070309020205020404" pitchFamily="49" charset="0"/>
+              </a:rPr>
+              <a:t>Memory</a:t>
+            </a:r>
+          </a:p>
+          <a:p>
+            <a:pPr lvl="1"/>
+            <a:r>
+              <a:rPr lang="en-US" b="1" dirty="0"/>
+              <a:t>Utilize</a:t>
+            </a:r>
+            <a:r>
+              <a:rPr lang="en-US" dirty="0"/>
+              <a:t> </a:t>
+            </a:r>
+            <a:r>
+              <a:rPr lang="en-US" i="1" dirty="0"/>
+              <a:t>recall/memory </a:t>
+            </a:r>
+            <a:r>
+              <a:rPr lang="en-US" dirty="0"/>
+              <a:t>that Gemini and other advanced LLMs possess</a:t>
+            </a:r>
+            <a:endParaRPr lang="en-US" dirty="0">
+              <a:cs typeface="Courier New" panose="02070309020205020404" pitchFamily="49" charset="0"/>
+            </a:endParaRPr>
+          </a:p>
+          <a:p>
+            <a:pPr lvl="1"/>
+            <a:endParaRPr lang="en-US" dirty="0">
+              <a:cs typeface="Courier New" panose="02070309020205020404" pitchFamily="49" charset="0"/>
+            </a:endParaRPr>
+          </a:p>
+          <a:p>
             <a:pPr lvl="2"/>
             <a:endParaRPr lang="en-US" dirty="0">
               <a:cs typeface="Courier New" panose="02070309020205020404" pitchFamily="49" charset="0"/>
@@ -6690,6 +6730,42 @@
           </a:p>
         </p:txBody>
       </p:sp>
+      <p:pic>
+        <p:nvPicPr>
+          <p:cNvPr id="4" name="Picture 3" descr="A red triangle on a black background&#10;&#10;AI-generated content may be incorrect.">
+            <a:extLst>
+              <a:ext uri="{FF2B5EF4-FFF2-40B4-BE49-F238E27FC236}">
+                <a16:creationId xmlns:a16="http://schemas.microsoft.com/office/drawing/2014/main" id="{EA7CE54B-6ED9-09AA-3329-3EB71BCD447E}"/>
+              </a:ext>
+            </a:extLst>
+          </p:cNvPr>
+          <p:cNvPicPr>
+            <a:picLocks noChangeAspect="1"/>
+          </p:cNvPicPr>
+          <p:nvPr/>
+        </p:nvPicPr>
+        <p:blipFill>
+          <a:blip r:embed="rId3">
+            <a:extLst>
+              <a:ext uri="{28A0092B-C50C-407E-A947-70E740481C1C}">
+                <a14:useLocalDpi xmlns:a14="http://schemas.microsoft.com/office/drawing/2010/main" val="0"/>
+              </a:ext>
+            </a:extLst>
+          </a:blip>
+          <a:stretch>
+            <a:fillRect/>
+          </a:stretch>
+        </p:blipFill>
+        <p:spPr>
+          <a:xfrm>
+            <a:off x="6841304" y="5039634"/>
+            <a:ext cx="421518" cy="421518"/>
+          </a:xfrm>
+          <a:prstGeom prst="rect">
+            <a:avLst/>
+          </a:prstGeom>
+        </p:spPr>
+      </p:pic>
     </p:spTree>
     <p:extLst>
       <p:ext uri="{BB962C8B-B14F-4D97-AF65-F5344CB8AC3E}">
@@ -7210,16 +7286,19 @@
               <a:rPr lang="en-US" dirty="0">
                 <a:cs typeface="Courier New" panose="02070309020205020404" pitchFamily="49" charset="0"/>
               </a:rPr>
-              <a:t>Cache results/data from tools calls for future look-ups</a:t>
-            </a:r>
-          </a:p>
-          <a:p>
-            <a:pPr lvl="1"/>
+              <a:t>Enhance </a:t>
+            </a:r>
+            <a:r>
+              <a:rPr lang="en-US" dirty="0" err="1">
+                <a:cs typeface="Courier New" panose="02070309020205020404" pitchFamily="49" charset="0"/>
+              </a:rPr>
+              <a:t>LangGraph</a:t>
+            </a:r>
             <a:r>
               <a:rPr lang="en-US" dirty="0">
                 <a:cs typeface="Courier New" panose="02070309020205020404" pitchFamily="49" charset="0"/>
               </a:rPr>
-              <a:t>Enhanced performance</a:t>
+              <a:t>: Handle parallel NE chains</a:t>
             </a:r>
           </a:p>
           <a:p>

</xml_diff>

<commit_message>
Added: 1. Memory 2. Alarms Simulation
</commit_message>
<xml_diff>
--- a/Presentation.pptx
+++ b/Presentation.pptx
@@ -213,7 +213,7 @@
           <a:p>
             <a:fld id="{F214320D-9E3A-43B2-B232-402D78146534}" type="datetimeFigureOut">
               <a:rPr lang="en-CA" smtClean="0"/>
-              <a:t>2025-07-07</a:t>
+              <a:t>2025-07-11</a:t>
             </a:fld>
             <a:endParaRPr lang="en-CA"/>
           </a:p>
@@ -1390,7 +1390,7 @@
           <a:p>
             <a:fld id="{C128FA71-3A18-48C0-980F-4B68F7F63042}" type="datetime1">
               <a:rPr lang="en-US" smtClean="0"/>
-              <a:t>7/7/2025</a:t>
+              <a:t>7/11/2025</a:t>
             </a:fld>
             <a:endParaRPr lang="en-US"/>
           </a:p>
@@ -1598,7 +1598,7 @@
           <a:p>
             <a:fld id="{7104EDB3-C0E8-45F8-9E1D-1B6C8D1880C0}" type="datetime1">
               <a:rPr lang="en-US" smtClean="0"/>
-              <a:t>7/7/2025</a:t>
+              <a:t>7/11/2025</a:t>
             </a:fld>
             <a:endParaRPr lang="en-US"/>
           </a:p>
@@ -1808,7 +1808,7 @@
           <a:p>
             <a:fld id="{9CF0EC4B-54ED-4041-B552-9BA760FA3DBA}" type="datetime1">
               <a:rPr lang="en-US" smtClean="0"/>
-              <a:t>7/7/2025</a:t>
+              <a:t>7/11/2025</a:t>
             </a:fld>
             <a:endParaRPr lang="en-US"/>
           </a:p>
@@ -2006,7 +2006,7 @@
           <a:p>
             <a:fld id="{51C1210E-201E-4473-82AC-2466F5386C38}" type="datetime1">
               <a:rPr lang="en-US" smtClean="0"/>
-              <a:t>7/7/2025</a:t>
+              <a:t>7/11/2025</a:t>
             </a:fld>
             <a:endParaRPr lang="en-US"/>
           </a:p>
@@ -2284,7 +2284,7 @@
           <a:p>
             <a:fld id="{B01EA198-6CAB-4B8F-B93F-1F9C8C4B6CE7}" type="datetime1">
               <a:rPr lang="en-US" smtClean="0"/>
-              <a:t>7/7/2025</a:t>
+              <a:t>7/11/2025</a:t>
             </a:fld>
             <a:endParaRPr lang="en-US"/>
           </a:p>
@@ -2556,7 +2556,7 @@
           <a:p>
             <a:fld id="{CA06041F-4525-44D5-AA4F-332294BF1F56}" type="datetime1">
               <a:rPr lang="en-US" smtClean="0"/>
-              <a:t>7/7/2025</a:t>
+              <a:t>7/11/2025</a:t>
             </a:fld>
             <a:endParaRPr lang="en-US"/>
           </a:p>
@@ -2980,7 +2980,7 @@
           <a:p>
             <a:fld id="{F9557091-BBDF-4EB9-BA6B-2BB67AC4FC0F}" type="datetime1">
               <a:rPr lang="en-US" smtClean="0"/>
-              <a:t>7/7/2025</a:t>
+              <a:t>7/11/2025</a:t>
             </a:fld>
             <a:endParaRPr lang="en-US"/>
           </a:p>
@@ -3121,7 +3121,7 @@
           <a:p>
             <a:fld id="{2D6B226B-77A6-410C-9796-083F278E0125}" type="datetime1">
               <a:rPr lang="en-US" smtClean="0"/>
-              <a:t>7/7/2025</a:t>
+              <a:t>7/11/2025</a:t>
             </a:fld>
             <a:endParaRPr lang="en-US"/>
           </a:p>
@@ -3234,7 +3234,7 @@
           <a:p>
             <a:fld id="{A23A578B-D289-4C40-8593-3D356C49DA58}" type="datetime1">
               <a:rPr lang="en-US" smtClean="0"/>
-              <a:t>7/7/2025</a:t>
+              <a:t>7/11/2025</a:t>
             </a:fld>
             <a:endParaRPr lang="en-US"/>
           </a:p>
@@ -3553,7 +3553,7 @@
           <a:p>
             <a:fld id="{713DFAE3-14DB-48A7-A80F-80DDB072CE3D}" type="datetime1">
               <a:rPr lang="en-US" smtClean="0"/>
-              <a:t>7/7/2025</a:t>
+              <a:t>7/11/2025</a:t>
             </a:fld>
             <a:endParaRPr lang="en-US"/>
           </a:p>
@@ -3847,7 +3847,7 @@
           <a:p>
             <a:fld id="{92C5EAEF-6478-4102-8F5D-A5FE9FC97ACB}" type="datetime1">
               <a:rPr lang="en-US" smtClean="0"/>
-              <a:t>7/7/2025</a:t>
+              <a:t>7/11/2025</a:t>
             </a:fld>
             <a:endParaRPr lang="en-US"/>
           </a:p>
@@ -4088,7 +4088,7 @@
           <a:p>
             <a:fld id="{67F45AC6-C491-4585-A584-9CE2AF7D5500}" type="datetime1">
               <a:rPr lang="en-US" smtClean="0"/>
-              <a:t>7/7/2025</a:t>
+              <a:t>7/11/2025</a:t>
             </a:fld>
             <a:endParaRPr lang="en-US"/>
           </a:p>
@@ -6491,9 +6491,35 @@
               <a:rPr lang="en-US" dirty="0"/>
               <a:t>that Gemini and other advanced LLMs possess</a:t>
             </a:r>
-            <a:endParaRPr lang="en-US" dirty="0">
-              <a:cs typeface="Courier New" panose="02070309020205020404" pitchFamily="49" charset="0"/>
-            </a:endParaRPr>
+          </a:p>
+          <a:p>
+            <a:r>
+              <a:rPr lang="en-US" dirty="0">
+                <a:cs typeface="Courier New" panose="02070309020205020404" pitchFamily="49" charset="0"/>
+              </a:rPr>
+              <a:t>Simulation</a:t>
+            </a:r>
+          </a:p>
+          <a:p>
+            <a:pPr lvl="1"/>
+            <a:r>
+              <a:rPr lang="en-US" b="1" dirty="0">
+                <a:cs typeface="Courier New" panose="02070309020205020404" pitchFamily="49" charset="0"/>
+              </a:rPr>
+              <a:t>Added</a:t>
+            </a:r>
+            <a:r>
+              <a:rPr lang="en-US" dirty="0">
+                <a:cs typeface="Courier New" panose="02070309020205020404" pitchFamily="49" charset="0"/>
+              </a:rPr>
+              <a:t> alarm-feed simulation for controlled/repeatable </a:t>
+            </a:r>
+            <a:r>
+              <a:rPr lang="en-US" i="1" dirty="0">
+                <a:cs typeface="Courier New" panose="02070309020205020404" pitchFamily="49" charset="0"/>
+              </a:rPr>
+              <a:t>testing</a:t>
+            </a:r>
           </a:p>
           <a:p>
             <a:pPr lvl="1"/>

</xml_diff>